<commit_message>
The presantation was fixed.
</commit_message>
<xml_diff>
--- a/docs/Elektrik_Piyasasi_Fiyat_Tahmini_Sunum.pptx
+++ b/docs/Elektrik_Piyasasi_Fiyat_Tahmini_Sunum.pptx
@@ -3935,7 +3935,7 @@
         </p:nvSpPr>
         <p:spPr>
           <a:xfrm>
-            <a:off x="0" y="0"/>
+            <a:off x="305" y="0"/>
             <a:ext cx="12191695" cy="6858000"/>
           </a:xfrm>
           <a:prstGeom prst="rect">
@@ -4039,7 +4039,7 @@
           <a:p>
             <a:pPr algn="l"/>
             <a:r>
-              <a:rPr sz="1400" b="1">
+              <a:rPr sz="1400" b="1" dirty="0">
                 <a:solidFill>
                   <a:srgbClr val="8AA0C2"/>
                 </a:solidFill>
@@ -4074,14 +4074,74 @@
           <a:p>
             <a:pPr algn="l"/>
             <a:r>
-              <a:rPr sz="4000" b="1">
+              <a:rPr sz="4000" b="1" dirty="0" err="1">
                 <a:solidFill>
                   <a:srgbClr val="FFFFFF"/>
                 </a:solidFill>
                 <a:latin typeface="Calibri"/>
               </a:rPr>
-              <a:t>Elektrik Piyasası Fiyat Tahmini</a:t>
-            </a:r>
+              <a:t>Elektrik</a:t>
+            </a:r>
+            <a:r>
+              <a:rPr sz="4000" b="1" dirty="0">
+                <a:solidFill>
+                  <a:srgbClr val="FFFFFF"/>
+                </a:solidFill>
+                <a:latin typeface="Calibri"/>
+              </a:rPr>
+              <a:t> </a:t>
+            </a:r>
+            <a:r>
+              <a:rPr sz="4000" b="1" dirty="0" err="1">
+                <a:solidFill>
+                  <a:srgbClr val="FFFFFF"/>
+                </a:solidFill>
+                <a:latin typeface="Calibri"/>
+              </a:rPr>
+              <a:t>Piyasası</a:t>
+            </a:r>
+            <a:r>
+              <a:rPr sz="4000" b="1" dirty="0">
+                <a:solidFill>
+                  <a:srgbClr val="FFFFFF"/>
+                </a:solidFill>
+                <a:latin typeface="Calibri"/>
+              </a:rPr>
+              <a:t> </a:t>
+            </a:r>
+            <a:r>
+              <a:rPr sz="4000" b="1" dirty="0" err="1">
+                <a:solidFill>
+                  <a:srgbClr val="FFFFFF"/>
+                </a:solidFill>
+                <a:latin typeface="Calibri"/>
+              </a:rPr>
+              <a:t>Fiyat</a:t>
+            </a:r>
+            <a:r>
+              <a:rPr sz="4000" b="1" dirty="0">
+                <a:solidFill>
+                  <a:srgbClr val="FFFFFF"/>
+                </a:solidFill>
+                <a:latin typeface="Calibri"/>
+              </a:rPr>
+              <a:t> </a:t>
+            </a:r>
+            <a:r>
+              <a:rPr sz="4000" b="1" dirty="0" err="1">
+                <a:solidFill>
+                  <a:srgbClr val="FFFFFF"/>
+                </a:solidFill>
+                <a:latin typeface="Calibri"/>
+              </a:rPr>
+              <a:t>Tahmini</a:t>
+            </a:r>
+            <a:endParaRPr sz="4000" b="1" dirty="0">
+              <a:solidFill>
+                <a:srgbClr val="FFFFFF"/>
+              </a:solidFill>
+              <a:latin typeface="Calibri"/>
+            </a:endParaRPr>
           </a:p>
         </p:txBody>
       </p:sp>
@@ -4109,48 +4169,112 @@
           <a:p>
             <a:pPr algn="l"/>
             <a:r>
-              <a:rPr sz="2000" b="0">
+              <a:rPr sz="2000" b="0" dirty="0" err="1">
                 <a:solidFill>
                   <a:srgbClr val="C5D0E0"/>
                 </a:solidFill>
                 <a:latin typeface="Calibri"/>
               </a:rPr>
-              <a:t>İspanya gün öncesi piyasası  ·  saatlik fiyat (€/MWh)  ·  2014–2018</a:t>
-            </a:r>
-          </a:p>
-        </p:txBody>
-      </p:sp>
-      <p:sp>
-        <p:nvSpPr>
-          <p:cNvPr id="7" name="TextBox 6"/>
-          <p:cNvSpPr txBox="1"/>
-          <p:nvPr/>
-        </p:nvSpPr>
-        <p:spPr>
-          <a:xfrm>
-            <a:off x="822960" y="4892040"/>
-            <a:ext cx="10515600" cy="365760"/>
-          </a:xfrm>
-          <a:prstGeom prst="rect">
-            <a:avLst/>
-          </a:prstGeom>
-          <a:noFill/>
-        </p:spPr>
-        <p:txBody>
-          <a:bodyPr wrap="none">
-            <a:spAutoFit/>
-          </a:bodyPr>
-          <a:lstStyle/>
-          <a:p>
-            <a:pPr algn="l"/>
-            <a:r>
-              <a:rPr sz="1800" b="1">
-                <a:solidFill>
-                  <a:srgbClr val="FFFFFF"/>
-                </a:solidFill>
-                <a:latin typeface="Calibri"/>
-              </a:rPr>
-              <a:t>Ridge (α = 0.001)  +  METHOD_B  +  AR(1)</a:t>
+              <a:t>İspanya</a:t>
+            </a:r>
+            <a:r>
+              <a:rPr sz="2000" b="0" dirty="0">
+                <a:solidFill>
+                  <a:srgbClr val="C5D0E0"/>
+                </a:solidFill>
+                <a:latin typeface="Calibri"/>
+              </a:rPr>
+              <a:t> </a:t>
+            </a:r>
+            <a:r>
+              <a:rPr sz="2000" b="0" dirty="0" err="1">
+                <a:solidFill>
+                  <a:srgbClr val="C5D0E0"/>
+                </a:solidFill>
+                <a:latin typeface="Calibri"/>
+              </a:rPr>
+              <a:t>gün</a:t>
+            </a:r>
+            <a:r>
+              <a:rPr sz="2000" b="0" dirty="0">
+                <a:solidFill>
+                  <a:srgbClr val="C5D0E0"/>
+                </a:solidFill>
+                <a:latin typeface="Calibri"/>
+              </a:rPr>
+              <a:t> </a:t>
+            </a:r>
+            <a:r>
+              <a:rPr sz="2000" b="0" dirty="0" err="1">
+                <a:solidFill>
+                  <a:srgbClr val="C5D0E0"/>
+                </a:solidFill>
+                <a:latin typeface="Calibri"/>
+              </a:rPr>
+              <a:t>öncesi</a:t>
+            </a:r>
+            <a:r>
+              <a:rPr sz="2000" b="0" dirty="0">
+                <a:solidFill>
+                  <a:srgbClr val="C5D0E0"/>
+                </a:solidFill>
+                <a:latin typeface="Calibri"/>
+              </a:rPr>
+              <a:t> </a:t>
+            </a:r>
+            <a:r>
+              <a:rPr sz="2000" b="0" dirty="0" err="1">
+                <a:solidFill>
+                  <a:srgbClr val="C5D0E0"/>
+                </a:solidFill>
+                <a:latin typeface="Calibri"/>
+              </a:rPr>
+              <a:t>piyasası</a:t>
+            </a:r>
+            <a:r>
+              <a:rPr sz="2000" b="0" dirty="0">
+                <a:solidFill>
+                  <a:srgbClr val="C5D0E0"/>
+                </a:solidFill>
+                <a:latin typeface="Calibri"/>
+              </a:rPr>
+              <a:t>  ·  </a:t>
+            </a:r>
+            <a:r>
+              <a:rPr sz="2000" b="0" dirty="0" err="1">
+                <a:solidFill>
+                  <a:srgbClr val="C5D0E0"/>
+                </a:solidFill>
+                <a:latin typeface="Calibri"/>
+              </a:rPr>
+              <a:t>saatlik</a:t>
+            </a:r>
+            <a:r>
+              <a:rPr sz="2000" b="0" dirty="0">
+                <a:solidFill>
+                  <a:srgbClr val="C5D0E0"/>
+                </a:solidFill>
+                <a:latin typeface="Calibri"/>
+              </a:rPr>
+              <a:t> </a:t>
+            </a:r>
+            <a:r>
+              <a:rPr sz="2000" b="0" dirty="0" err="1">
+                <a:solidFill>
+                  <a:srgbClr val="C5D0E0"/>
+                </a:solidFill>
+                <a:latin typeface="Calibri"/>
+              </a:rPr>
+              <a:t>fiyat</a:t>
+            </a:r>
+            <a:r>
+              <a:rPr sz="2000" b="0" dirty="0">
+                <a:solidFill>
+                  <a:srgbClr val="C5D0E0"/>
+                </a:solidFill>
+                <a:latin typeface="Calibri"/>
+              </a:rPr>
+              <a:t> (€/MWh)  ·  2014–2018</a:t>
             </a:r>
           </a:p>
         </p:txBody>

</xml_diff>